<commit_message>
Finalize personalized reports and submission checklist
</commit_message>
<xml_diff>
--- a/deliverables/presentation.pptx
+++ b/deliverables/presentation.pptx
@@ -2,26 +2,26 @@
 <file path=ppt/presentation.xml><?xml version="1.0" encoding="utf-8"?>
 <p:presentation xmlns:p="http://schemas.openxmlformats.org/presentationml/2006/main">
   <p:sldMasterIdLst>
-    <p:sldMasterId xmlns:r="http://schemas.openxmlformats.org/officeDocument/2006/relationships" id="2147483648" r:id="R5d01cdc8bd3b47f9"/>
+    <p:sldMasterId xmlns:r="http://schemas.openxmlformats.org/officeDocument/2006/relationships" id="2147483648" r:id="R49199e5206cf4f02"/>
   </p:sldMasterIdLst>
   <p:notesMasterIdLst>
-    <p:notesMasterId xmlns:r="http://schemas.openxmlformats.org/officeDocument/2006/relationships" r:id="R52e6112946e14088"/>
+    <p:notesMasterId xmlns:r="http://schemas.openxmlformats.org/officeDocument/2006/relationships" r:id="Rabf07cf888034b4c"/>
   </p:notesMasterIdLst>
   <p:sldIdLst>
-    <p:sldId xmlns:r="http://schemas.openxmlformats.org/officeDocument/2006/relationships" id="256" r:id="R2cebbf27e1294721"/>
-    <p:sldId xmlns:r="http://schemas.openxmlformats.org/officeDocument/2006/relationships" id="257" r:id="Re01cc4533def47b5"/>
-    <p:sldId xmlns:r="http://schemas.openxmlformats.org/officeDocument/2006/relationships" id="258" r:id="R4f0b58e10cdf42cf"/>
-    <p:sldId xmlns:r="http://schemas.openxmlformats.org/officeDocument/2006/relationships" id="259" r:id="R8479accc12544b5c"/>
-    <p:sldId xmlns:r="http://schemas.openxmlformats.org/officeDocument/2006/relationships" id="260" r:id="R9b1923ba7cf94274"/>
-    <p:sldId xmlns:r="http://schemas.openxmlformats.org/officeDocument/2006/relationships" id="261" r:id="Rc1fe4ccff4124cec"/>
-    <p:sldId xmlns:r="http://schemas.openxmlformats.org/officeDocument/2006/relationships" id="262" r:id="R716400bb88604105"/>
-    <p:sldId xmlns:r="http://schemas.openxmlformats.org/officeDocument/2006/relationships" id="263" r:id="R1f8737a8d068491d"/>
-    <p:sldId xmlns:r="http://schemas.openxmlformats.org/officeDocument/2006/relationships" id="264" r:id="R89c0fccba1ab45c1"/>
-    <p:sldId xmlns:r="http://schemas.openxmlformats.org/officeDocument/2006/relationships" id="265" r:id="R8f5672902d8d4005"/>
-    <p:sldId xmlns:r="http://schemas.openxmlformats.org/officeDocument/2006/relationships" id="266" r:id="Rc054fb837216434f"/>
-    <p:sldId xmlns:r="http://schemas.openxmlformats.org/officeDocument/2006/relationships" id="267" r:id="Rddb3a01026aa4f84"/>
-    <p:sldId xmlns:r="http://schemas.openxmlformats.org/officeDocument/2006/relationships" id="268" r:id="R6c86208563f04f32"/>
-    <p:sldId xmlns:r="http://schemas.openxmlformats.org/officeDocument/2006/relationships" id="269" r:id="R8effc938ef4c4d62"/>
+    <p:sldId xmlns:r="http://schemas.openxmlformats.org/officeDocument/2006/relationships" id="256" r:id="R43018ec8c4d7432d"/>
+    <p:sldId xmlns:r="http://schemas.openxmlformats.org/officeDocument/2006/relationships" id="257" r:id="R458178e93e034574"/>
+    <p:sldId xmlns:r="http://schemas.openxmlformats.org/officeDocument/2006/relationships" id="258" r:id="R016b7f1e55554d4a"/>
+    <p:sldId xmlns:r="http://schemas.openxmlformats.org/officeDocument/2006/relationships" id="259" r:id="R9947fea682ba483c"/>
+    <p:sldId xmlns:r="http://schemas.openxmlformats.org/officeDocument/2006/relationships" id="260" r:id="Rfb906343c3d54086"/>
+    <p:sldId xmlns:r="http://schemas.openxmlformats.org/officeDocument/2006/relationships" id="261" r:id="R81b4b1d224134bce"/>
+    <p:sldId xmlns:r="http://schemas.openxmlformats.org/officeDocument/2006/relationships" id="262" r:id="R956ae24884bc4220"/>
+    <p:sldId xmlns:r="http://schemas.openxmlformats.org/officeDocument/2006/relationships" id="263" r:id="R471fc57f253244a4"/>
+    <p:sldId xmlns:r="http://schemas.openxmlformats.org/officeDocument/2006/relationships" id="264" r:id="Ra9b81c398fea4d4f"/>
+    <p:sldId xmlns:r="http://schemas.openxmlformats.org/officeDocument/2006/relationships" id="265" r:id="R438981aab10d4cab"/>
+    <p:sldId xmlns:r="http://schemas.openxmlformats.org/officeDocument/2006/relationships" id="266" r:id="Rfbda1d6b6ae346be"/>
+    <p:sldId xmlns:r="http://schemas.openxmlformats.org/officeDocument/2006/relationships" id="267" r:id="R7ea51e07601a4c58"/>
+    <p:sldId xmlns:r="http://schemas.openxmlformats.org/officeDocument/2006/relationships" id="268" r:id="R5d31c5edc56942c1"/>
+    <p:sldId xmlns:r="http://schemas.openxmlformats.org/officeDocument/2006/relationships" id="269" r:id="R28cd250feaeb481e"/>
   </p:sldIdLst>
   <p:sldSz cx="12192000" cy="6858000"/>
   <p:notesSz cx="6858000" cy="9144000"/>
@@ -1015,7 +1015,7 @@
           <a:lstStyle xmlns:a="http://schemas.openxmlformats.org/drawingml/2006/main"/>
           <a:p xmlns:a="http://schemas.openxmlformats.org/drawingml/2006/main">
             <a:r>
-              <a:t>Source: src/bankruptcy/train.py, reports/experiment_config.json and reports/split_manifest.csv. A stratified 80/20 split uses seed 42. Development has 8,332 rows and 394 positives, test has 2,084 rows and 99 positives. All six models use the same 3 folds. Selection uses mean fold average precision. The selected modelâ€™s OOF scores set the F2 threshold. The model is refitted on all development rows and evaluated on the fixed test set. No test-driven changes are made.</a:t>
+              <a:t>Source: src/bankruptcy/train.py, reports/experiment_config.json and reports/split_manifest.csv. A stratified 80/20 split uses seed 42. Development has 8,332 rows and 394 positives, test has 2,084 rows and 99 positives. All six models use the same 3 folds. Selection uses mean fold average precision. The selected model’s OOF scores set the F2 threshold. The model is refitted on all development rows and evaluated on the fixed test set. No test-driven changes are made.</a:t>
             </a:r>
           </a:p>
         </p:txBody>
@@ -1225,7 +1225,7 @@
           <a:lstStyle xmlns:a="http://schemas.openxmlformats.org/drawingml/2006/main"/>
           <a:p xmlns:a="http://schemas.openxmlformats.org/drawingml/2006/main">
             <a:r>
-              <a:t>Source: reports/threshold_curve.csv and reports/metrics.json. OOF means out-of-fold predictions: each development row is scored by a model not fitted on that row. The threshold maximizes F2 on the selected modelâ€™s OOF scores. F2 = 5PR/(4P+R). The chosen threshold is 0.1979516978. This is a declared academic screening objective, not a monetary cost model. Because the same CV is used for selection, development scores can be optimistic; test results remain separate.</a:t>
+              <a:t>Source: reports/threshold_curve.csv and reports/metrics.json. OOF means out-of-fold predictions: each development row is scored by a model not fitted on that row. The threshold maximizes F2 on the selected model’s OOF scores. F2 = 5PR/(4P+R). The chosen threshold is 0.1979516978. This is a declared academic screening objective, not a monetary cost model. Because the same CV is used for selection, development scores can be optimistic; test results remain separate.</a:t>
             </a:r>
           </a:p>
         </p:txBody>
@@ -1295,7 +1295,7 @@
           <a:lstStyle xmlns:a="http://schemas.openxmlformats.org/drawingml/2006/main"/>
           <a:p xmlns:a="http://schemas.openxmlformats.org/drawingml/2006/main">
             <a:r>
-              <a:t>Source: reports/metrics.json and reports/test_predictions.csv. Independent test counts are TN 1824, FP 161, FN 15, TP 84. Recall 84.85%, precision 34.29%, AP 0.7495, ROC AUC 0.9677. The all-negative baseline has 95.25% accuracy and zero recall. Approximate stratified bootstrap 95% recall interval: 77.8â€“91.9%; precision interval: 31.1â€“38.7%. These intervals condition on this fitted model and split.</a:t>
+              <a:t>Source: reports/metrics.json and reports/test_predictions.csv. Independent test counts are TN 1824, FP 161, FN 15, TP 84. Recall 84.85%, precision 34.29%, AP 0.7495, ROC AUC 0.9677. The all-negative baseline has 95.25% accuracy and zero recall. Approximate stratified bootstrap 95% recall interval: 77.8–91.9%; precision interval: 31.1–38.7%. These intervals condition on this fitted model and split.</a:t>
             </a:r>
           </a:p>
         </p:txBody>
@@ -1412,7 +1412,7 @@
           <p:cNvPr id="3" name="Title">
             <a:extLst xmlns:a="http://schemas.openxmlformats.org/drawingml/2006/main">
               <a:ext uri="{FF2B5EF4-FFF2-40B4-BE49-F238E27FC236}">
-                <a16:creationId xmlns:a16="http://schemas.microsoft.com/office/drawing/2014/main" id="{E865033B-A44A-4F92-B812-C3428B46C3A2}"/>
+                <a16:creationId xmlns:a16="http://schemas.microsoft.com/office/drawing/2014/main" id="{26B56AB6-6652-47C3-AF29-37525BABCC89}"/>
               </a:ext>
             </a:extLst>
           </p:cNvPr>
@@ -1569,7 +1569,7 @@
           <p:cNvPr id="2" name="Subtitle">
             <a:extLst xmlns:a="http://schemas.openxmlformats.org/drawingml/2006/main">
               <a:ext uri="{FF2B5EF4-FFF2-40B4-BE49-F238E27FC236}">
-                <a16:creationId xmlns:a16="http://schemas.microsoft.com/office/drawing/2014/main" id="{EA9B4225-9E5D-46F0-BD9D-28DC572DBD61}"/>
+                <a16:creationId xmlns:a16="http://schemas.microsoft.com/office/drawing/2014/main" id="{6040560A-F152-4B35-8FC5-B203579B7549}"/>
               </a:ext>
             </a:extLst>
           </p:cNvPr>
@@ -1743,7 +1743,7 @@
           <p:cNvPr id="2" name="Section title">
             <a:extLst xmlns:a="http://schemas.openxmlformats.org/drawingml/2006/main">
               <a:ext uri="{FF2B5EF4-FFF2-40B4-BE49-F238E27FC236}">
-                <a16:creationId xmlns:a16="http://schemas.microsoft.com/office/drawing/2014/main" id="{DDC2BED3-4BF1-4FC4-AAF9-C08E8AA7330A}"/>
+                <a16:creationId xmlns:a16="http://schemas.microsoft.com/office/drawing/2014/main" id="{E1971C67-CC71-4BB2-B3B9-54CE59DE1605}"/>
               </a:ext>
             </a:extLst>
           </p:cNvPr>
@@ -1917,7 +1917,7 @@
           <p:cNvPr id="3" name="Title">
             <a:extLst xmlns:a="http://schemas.openxmlformats.org/drawingml/2006/main">
               <a:ext uri="{FF2B5EF4-FFF2-40B4-BE49-F238E27FC236}">
-                <a16:creationId xmlns:a16="http://schemas.microsoft.com/office/drawing/2014/main" id="{5E322D63-1FE8-4F88-B366-2EB3ED26BEAA}"/>
+                <a16:creationId xmlns:a16="http://schemas.microsoft.com/office/drawing/2014/main" id="{302E5FDD-7E8E-4FD7-907F-A47B296841B6}"/>
               </a:ext>
             </a:extLst>
           </p:cNvPr>
@@ -2074,7 +2074,7 @@
           <p:cNvPr id="2" name="Body">
             <a:extLst xmlns:a="http://schemas.openxmlformats.org/drawingml/2006/main">
               <a:ext uri="{FF2B5EF4-FFF2-40B4-BE49-F238E27FC236}">
-                <a16:creationId xmlns:a16="http://schemas.microsoft.com/office/drawing/2014/main" id="{4E27FA9C-5359-4685-BC01-FDE105D90E38}"/>
+                <a16:creationId xmlns:a16="http://schemas.microsoft.com/office/drawing/2014/main" id="{1D1BD857-E216-4B8B-9601-BF3A24D65F23}"/>
               </a:ext>
             </a:extLst>
           </p:cNvPr>
@@ -2248,7 +2248,7 @@
           <p:cNvPr id="4" name="Title">
             <a:extLst xmlns:a="http://schemas.openxmlformats.org/drawingml/2006/main">
               <a:ext uri="{FF2B5EF4-FFF2-40B4-BE49-F238E27FC236}">
-                <a16:creationId xmlns:a16="http://schemas.microsoft.com/office/drawing/2014/main" id="{97918B28-AE02-454E-97A5-6563D9E7BE8A}"/>
+                <a16:creationId xmlns:a16="http://schemas.microsoft.com/office/drawing/2014/main" id="{B89EB6AE-B6C8-47AC-84CB-34DE9CDB8487}"/>
               </a:ext>
             </a:extLst>
           </p:cNvPr>
@@ -2405,7 +2405,7 @@
           <p:cNvPr id="2" name="Left column">
             <a:extLst xmlns:a="http://schemas.openxmlformats.org/drawingml/2006/main">
               <a:ext uri="{FF2B5EF4-FFF2-40B4-BE49-F238E27FC236}">
-                <a16:creationId xmlns:a16="http://schemas.microsoft.com/office/drawing/2014/main" id="{FEBEDC03-2E4C-4452-AEBE-AFC71A071800}"/>
+                <a16:creationId xmlns:a16="http://schemas.microsoft.com/office/drawing/2014/main" id="{F9FDC89A-075D-4D75-9367-A4E0F218EDAC}"/>
               </a:ext>
             </a:extLst>
           </p:cNvPr>
@@ -2562,7 +2562,7 @@
           <p:cNvPr id="3" name="Right column">
             <a:extLst xmlns:a="http://schemas.openxmlformats.org/drawingml/2006/main">
               <a:ext uri="{FF2B5EF4-FFF2-40B4-BE49-F238E27FC236}">
-                <a16:creationId xmlns:a16="http://schemas.microsoft.com/office/drawing/2014/main" id="{8C1A7D68-F417-49A0-8B47-7E5E89C70F26}"/>
+                <a16:creationId xmlns:a16="http://schemas.microsoft.com/office/drawing/2014/main" id="{EE022385-72D9-4F64-B569-75AC263EB0E9}"/>
               </a:ext>
             </a:extLst>
           </p:cNvPr>
@@ -2736,7 +2736,7 @@
           <p:cNvPr id="3" name="Title">
             <a:extLst xmlns:a="http://schemas.openxmlformats.org/drawingml/2006/main">
               <a:ext uri="{FF2B5EF4-FFF2-40B4-BE49-F238E27FC236}">
-                <a16:creationId xmlns:a16="http://schemas.microsoft.com/office/drawing/2014/main" id="{60E4F8C0-A882-4BDA-8D62-CEE330C4C1F0}"/>
+                <a16:creationId xmlns:a16="http://schemas.microsoft.com/office/drawing/2014/main" id="{ACD4A4CD-6A37-428E-9E75-D76F40793D7B}"/>
               </a:ext>
             </a:extLst>
           </p:cNvPr>
@@ -2893,7 +2893,7 @@
           <p:cNvPr id="2" name="Left column">
             <a:extLst xmlns:a="http://schemas.openxmlformats.org/drawingml/2006/main">
               <a:ext uri="{FF2B5EF4-FFF2-40B4-BE49-F238E27FC236}">
-                <a16:creationId xmlns:a16="http://schemas.microsoft.com/office/drawing/2014/main" id="{9DDFAAAE-8BE7-42EC-9F1C-E090DDC17C42}"/>
+                <a16:creationId xmlns:a16="http://schemas.microsoft.com/office/drawing/2014/main" id="{273D5A20-3331-4312-8B42-3241A8660D75}"/>
               </a:ext>
             </a:extLst>
           </p:cNvPr>
@@ -3088,12 +3088,12 @@
   </p:cSld>
   <p:clrMap bg1="lt1" tx1="dk1" bg2="lt2" tx2="dk2" accent1="accent1" accent2="accent2" accent3="accent3" accent4="accent4" accent5="accent5" accent6="accent6" hlink="hlink" folHlink="folHlink"/>
   <p:sldLayoutIdLst>
-    <p:sldLayoutId xmlns:r="http://schemas.openxmlformats.org/officeDocument/2006/relationships" id="2147483649" r:id="R77f53c4bf18b4528"/>
-    <p:sldLayoutId xmlns:r="http://schemas.openxmlformats.org/officeDocument/2006/relationships" id="2147483650" r:id="R829ab8bac58646fa"/>
-    <p:sldLayoutId xmlns:r="http://schemas.openxmlformats.org/officeDocument/2006/relationships" id="2147483651" r:id="R809f05e2acf84005"/>
-    <p:sldLayoutId xmlns:r="http://schemas.openxmlformats.org/officeDocument/2006/relationships" id="2147483652" r:id="Red9df0041ef347b7"/>
-    <p:sldLayoutId xmlns:r="http://schemas.openxmlformats.org/officeDocument/2006/relationships" id="2147483653" r:id="Rb23703a3257d4a7f"/>
-    <p:sldLayoutId xmlns:r="http://schemas.openxmlformats.org/officeDocument/2006/relationships" id="2147483654" r:id="R945f4f439c414352"/>
+    <p:sldLayoutId xmlns:r="http://schemas.openxmlformats.org/officeDocument/2006/relationships" id="2147483649" r:id="R228610d9a1454ff3"/>
+    <p:sldLayoutId xmlns:r="http://schemas.openxmlformats.org/officeDocument/2006/relationships" id="2147483650" r:id="R177b7ec76f7e477d"/>
+    <p:sldLayoutId xmlns:r="http://schemas.openxmlformats.org/officeDocument/2006/relationships" id="2147483651" r:id="R66725ce8a6ee4401"/>
+    <p:sldLayoutId xmlns:r="http://schemas.openxmlformats.org/officeDocument/2006/relationships" id="2147483652" r:id="R0848bb37355b4ed7"/>
+    <p:sldLayoutId xmlns:r="http://schemas.openxmlformats.org/officeDocument/2006/relationships" id="2147483653" r:id="Ra1add455ecca4755"/>
+    <p:sldLayoutId xmlns:r="http://schemas.openxmlformats.org/officeDocument/2006/relationships" id="2147483654" r:id="R02c421af6d7244c4"/>
   </p:sldLayoutIdLst>
   <p:txStyles>
     <p:titleStyle>
@@ -7931,7 +7931,7 @@
           <p:cNvPr id="6" name="">
             <a:extLst xmlns:a="http://schemas.openxmlformats.org/drawingml/2006/main">
               <a:ext uri="{FF2B5EF4-FFF2-40B4-BE49-F238E27FC236}">
-                <a16:creationId xmlns:a16="http://schemas.microsoft.com/office/drawing/2014/main" id="{99DD2F36-19FB-41C9-9B3C-3DE35AE2C8B5}"/>
+                <a16:creationId xmlns:a16="http://schemas.microsoft.com/office/drawing/2014/main" id="{AC7C1A0C-799B-4205-8185-16A6AA2CF3EA}"/>
               </a:ext>
             </a:extLst>
           </p:cNvPr>
@@ -7999,7 +7999,7 @@
           <p:cNvPr id="2" name="">
             <a:extLst xmlns:a="http://schemas.openxmlformats.org/drawingml/2006/main">
               <a:ext uri="{FF2B5EF4-FFF2-40B4-BE49-F238E27FC236}">
-                <a16:creationId xmlns:a16="http://schemas.microsoft.com/office/drawing/2014/main" id="{E24B89D1-8FBA-4B8A-ADB8-F248BD69D350}"/>
+                <a16:creationId xmlns:a16="http://schemas.microsoft.com/office/drawing/2014/main" id="{C29EC2E5-77FE-40A3-9FD5-0130C204744D}"/>
               </a:ext>
             </a:extLst>
           </p:cNvPr>
@@ -8067,7 +8067,7 @@
           <p:cNvPr id="3" name="">
             <a:extLst xmlns:a="http://schemas.openxmlformats.org/drawingml/2006/main">
               <a:ext uri="{FF2B5EF4-FFF2-40B4-BE49-F238E27FC236}">
-                <a16:creationId xmlns:a16="http://schemas.microsoft.com/office/drawing/2014/main" id="{4481A010-26C1-41FE-B1D3-D62EF094DC17}"/>
+                <a16:creationId xmlns:a16="http://schemas.microsoft.com/office/drawing/2014/main" id="{C0B54109-3CAA-46E1-A0E7-40299D44D6E2}"/>
               </a:ext>
             </a:extLst>
           </p:cNvPr>
@@ -8158,7 +8158,7 @@
           <p:cNvPr id="4" name="">
             <a:extLst xmlns:a="http://schemas.openxmlformats.org/drawingml/2006/main">
               <a:ext uri="{FF2B5EF4-FFF2-40B4-BE49-F238E27FC236}">
-                <a16:creationId xmlns:a16="http://schemas.microsoft.com/office/drawing/2014/main" id="{9FFB19CA-BD35-4020-80DB-61DC6BF189F4}"/>
+                <a16:creationId xmlns:a16="http://schemas.microsoft.com/office/drawing/2014/main" id="{87D8ACF8-CB98-4362-9EA5-05F42BE4074E}"/>
               </a:ext>
             </a:extLst>
           </p:cNvPr>
@@ -8226,7 +8226,7 @@
           <p:cNvPr id="5" name="">
             <a:extLst xmlns:a="http://schemas.openxmlformats.org/drawingml/2006/main">
               <a:ext uri="{FF2B5EF4-FFF2-40B4-BE49-F238E27FC236}">
-                <a16:creationId xmlns:a16="http://schemas.microsoft.com/office/drawing/2014/main" id="{F617E456-6FB9-40D1-ACA7-55A90DB69015}"/>
+                <a16:creationId xmlns:a16="http://schemas.microsoft.com/office/drawing/2014/main" id="{AFE3EA9C-0014-4BCD-B1B5-1D4303D22758}"/>
               </a:ext>
             </a:extLst>
           </p:cNvPr>
@@ -8315,7 +8315,7 @@
     </p:spTree>
     <p:extLst>
       <p:ext uri="{BB962C8B-B14F-4D97-AF65-F5344CB8AC3E}">
-        <p14:creationId xmlns:p14="http://schemas.microsoft.com/office/powerpoint/2010/main" val="1909387379"/>
+        <p14:creationId xmlns:p14="http://schemas.microsoft.com/office/powerpoint/2010/main" val="1698621815"/>
       </p:ext>
     </p:extLst>
   </p:cSld>
@@ -8346,7 +8346,7 @@
           <p:cNvPr id="8" name="">
             <a:extLst xmlns:a="http://schemas.openxmlformats.org/drawingml/2006/main">
               <a:ext uri="{FF2B5EF4-FFF2-40B4-BE49-F238E27FC236}">
-                <a16:creationId xmlns:a16="http://schemas.microsoft.com/office/drawing/2014/main" id="{6E9BFC2E-AB90-43CE-87DA-099A64CD2F5C}"/>
+                <a16:creationId xmlns:a16="http://schemas.microsoft.com/office/drawing/2014/main" id="{EACB6442-98CA-466F-AC97-9987D414BAA9}"/>
               </a:ext>
             </a:extLst>
           </p:cNvPr>
@@ -8414,7 +8414,7 @@
           <p:cNvPr id="2" name="">
             <a:extLst xmlns:a="http://schemas.openxmlformats.org/drawingml/2006/main">
               <a:ext uri="{FF2B5EF4-FFF2-40B4-BE49-F238E27FC236}">
-                <a16:creationId xmlns:a16="http://schemas.microsoft.com/office/drawing/2014/main" id="{3D8E8FB5-E475-4A56-B449-5930C9521A67}"/>
+                <a16:creationId xmlns:a16="http://schemas.microsoft.com/office/drawing/2014/main" id="{F694A754-752C-430D-89C7-76692D5A06B3}"/>
               </a:ext>
             </a:extLst>
           </p:cNvPr>
@@ -8482,7 +8482,7 @@
           <p:cNvPr id="3" name="">
             <a:extLst xmlns:a="http://schemas.openxmlformats.org/drawingml/2006/main">
               <a:ext uri="{FF2B5EF4-FFF2-40B4-BE49-F238E27FC236}">
-                <a16:creationId xmlns:a16="http://schemas.microsoft.com/office/drawing/2014/main" id="{15CBE7C4-B157-4A41-A86B-C79830965DED}"/>
+                <a16:creationId xmlns:a16="http://schemas.microsoft.com/office/drawing/2014/main" id="{C98156BF-E97F-4DBF-B6ED-9494C93158D7}"/>
               </a:ext>
             </a:extLst>
           </p:cNvPr>
@@ -8879,7 +8879,7 @@
           <p:cNvPr id="4" name="">
             <a:extLst xmlns:a="http://schemas.openxmlformats.org/drawingml/2006/main">
               <a:ext uri="{FF2B5EF4-FFF2-40B4-BE49-F238E27FC236}">
-                <a16:creationId xmlns:a16="http://schemas.microsoft.com/office/drawing/2014/main" id="{08CC8B88-6578-4679-BA9D-DCDC33D0B9EF}"/>
+                <a16:creationId xmlns:a16="http://schemas.microsoft.com/office/drawing/2014/main" id="{B90A5473-789E-4C10-BFEA-8EA04E7C9A83}"/>
               </a:ext>
             </a:extLst>
           </p:cNvPr>
@@ -8947,7 +8947,7 @@
           <p:cNvPr id="5" name="">
             <a:extLst xmlns:a="http://schemas.openxmlformats.org/drawingml/2006/main">
               <a:ext uri="{FF2B5EF4-FFF2-40B4-BE49-F238E27FC236}">
-                <a16:creationId xmlns:a16="http://schemas.microsoft.com/office/drawing/2014/main" id="{F5D054AD-5C08-4065-822A-9C139FCBA249}"/>
+                <a16:creationId xmlns:a16="http://schemas.microsoft.com/office/drawing/2014/main" id="{6D756AC7-ED96-48B5-9D49-3EDCCD3C16C7}"/>
               </a:ext>
             </a:extLst>
           </p:cNvPr>
@@ -9015,7 +9015,7 @@
           <p:cNvPr id="6" name="">
             <a:extLst xmlns:a="http://schemas.openxmlformats.org/drawingml/2006/main">
               <a:ext uri="{FF2B5EF4-FFF2-40B4-BE49-F238E27FC236}">
-                <a16:creationId xmlns:a16="http://schemas.microsoft.com/office/drawing/2014/main" id="{0CDEFE3E-929C-41F0-A38C-1F9067C3C0F5}"/>
+                <a16:creationId xmlns:a16="http://schemas.microsoft.com/office/drawing/2014/main" id="{BA3C25C4-C738-4517-BC80-88AB012BE1CD}"/>
               </a:ext>
             </a:extLst>
           </p:cNvPr>
@@ -9083,7 +9083,7 @@
           <p:cNvPr id="7" name="">
             <a:extLst xmlns:a="http://schemas.openxmlformats.org/drawingml/2006/main">
               <a:ext uri="{FF2B5EF4-FFF2-40B4-BE49-F238E27FC236}">
-                <a16:creationId xmlns:a16="http://schemas.microsoft.com/office/drawing/2014/main" id="{43A5ADB7-E010-4CA3-B046-444D012ED0B1}"/>
+                <a16:creationId xmlns:a16="http://schemas.microsoft.com/office/drawing/2014/main" id="{628EE4C8-CB21-4492-8F1E-D43189B87D89}"/>
               </a:ext>
             </a:extLst>
           </p:cNvPr>
@@ -9149,7 +9149,7 @@
     </p:spTree>
     <p:extLst>
       <p:ext uri="{BB962C8B-B14F-4D97-AF65-F5344CB8AC3E}">
-        <p14:creationId xmlns:p14="http://schemas.microsoft.com/office/powerpoint/2010/main" val="1441449225"/>
+        <p14:creationId xmlns:p14="http://schemas.microsoft.com/office/powerpoint/2010/main" val="294287991"/>
       </p:ext>
     </p:extLst>
   </p:cSld>
@@ -9180,7 +9180,7 @@
           <p:cNvPr id="9" name="">
             <a:extLst xmlns:a="http://schemas.openxmlformats.org/drawingml/2006/main">
               <a:ext uri="{FF2B5EF4-FFF2-40B4-BE49-F238E27FC236}">
-                <a16:creationId xmlns:a16="http://schemas.microsoft.com/office/drawing/2014/main" id="{A2E0D9AB-F3BE-4887-98E1-C6587F6F38AF}"/>
+                <a16:creationId xmlns:a16="http://schemas.microsoft.com/office/drawing/2014/main" id="{C065FAF5-9778-435A-9E62-0F3AE149311B}"/>
               </a:ext>
             </a:extLst>
           </p:cNvPr>
@@ -9248,7 +9248,7 @@
           <p:cNvPr id="2" name="">
             <a:extLst xmlns:a="http://schemas.openxmlformats.org/drawingml/2006/main">
               <a:ext uri="{FF2B5EF4-FFF2-40B4-BE49-F238E27FC236}">
-                <a16:creationId xmlns:a16="http://schemas.microsoft.com/office/drawing/2014/main" id="{6B0B1F01-4CF3-467C-BE19-23E9D57E64CB}"/>
+                <a16:creationId xmlns:a16="http://schemas.microsoft.com/office/drawing/2014/main" id="{2B7527EE-766B-46A9-B013-E9D70312B2CC}"/>
               </a:ext>
             </a:extLst>
           </p:cNvPr>
@@ -9316,7 +9316,7 @@
           <p:cNvPr id="3" name="Chart">
             <a:extLst xmlns:a="http://schemas.openxmlformats.org/drawingml/2006/main">
               <a:ext uri="{FF2B5EF4-FFF2-40B4-BE49-F238E27FC236}">
-                <a16:creationId xmlns:a16="http://schemas.microsoft.com/office/drawing/2014/main" id="{93E15F01-96EA-4B93-8DF3-4F8D4F758136}"/>
+                <a16:creationId xmlns:a16="http://schemas.microsoft.com/office/drawing/2014/main" id="{18A5E660-D611-493C-ABBA-5EA1B63E75AF}"/>
               </a:ext>
             </a:extLst>
           </p:cNvPr>
@@ -9329,7 +9329,7 @@
         </p:xfrm>
         <a:graphic xmlns:a="http://schemas.openxmlformats.org/drawingml/2006/main">
           <a:graphicData uri="http://schemas.openxmlformats.org/drawingml/2006/chart">
-            <c:chart xmlns:r="http://schemas.openxmlformats.org/officeDocument/2006/relationships" xmlns:c="http://schemas.openxmlformats.org/drawingml/2006/chart" r:id="R85099c1a09634a4e"/>
+            <c:chart xmlns:r="http://schemas.openxmlformats.org/officeDocument/2006/relationships" xmlns:c="http://schemas.openxmlformats.org/drawingml/2006/chart" r:id="Rb297af145ce34be8"/>
           </a:graphicData>
         </a:graphic>
       </p:graphicFrame>
@@ -9338,7 +9338,7 @@
           <p:cNvPr id="4" name="">
             <a:extLst xmlns:a="http://schemas.openxmlformats.org/drawingml/2006/main">
               <a:ext uri="{FF2B5EF4-FFF2-40B4-BE49-F238E27FC236}">
-                <a16:creationId xmlns:a16="http://schemas.microsoft.com/office/drawing/2014/main" id="{DC7A67F9-4E22-40EA-8638-25097F1C5D6C}"/>
+                <a16:creationId xmlns:a16="http://schemas.microsoft.com/office/drawing/2014/main" id="{95F74F6C-1CF6-4F53-9B03-8D8FE7C269AF}"/>
               </a:ext>
             </a:extLst>
           </p:cNvPr>
@@ -9406,7 +9406,7 @@
           <p:cNvPr id="5" name="">
             <a:extLst xmlns:a="http://schemas.openxmlformats.org/drawingml/2006/main">
               <a:ext uri="{FF2B5EF4-FFF2-40B4-BE49-F238E27FC236}">
-                <a16:creationId xmlns:a16="http://schemas.microsoft.com/office/drawing/2014/main" id="{7AA7354B-AB14-4D79-85FD-789D84D55F80}"/>
+                <a16:creationId xmlns:a16="http://schemas.microsoft.com/office/drawing/2014/main" id="{D0522E46-039A-429B-9B23-5E0FC4B2FDBD}"/>
               </a:ext>
             </a:extLst>
           </p:cNvPr>
@@ -9497,7 +9497,7 @@
           <p:cNvPr id="6" name="">
             <a:extLst xmlns:a="http://schemas.openxmlformats.org/drawingml/2006/main">
               <a:ext uri="{FF2B5EF4-FFF2-40B4-BE49-F238E27FC236}">
-                <a16:creationId xmlns:a16="http://schemas.microsoft.com/office/drawing/2014/main" id="{D343D182-AA85-43E4-A656-8FA3F6079A0F}"/>
+                <a16:creationId xmlns:a16="http://schemas.microsoft.com/office/drawing/2014/main" id="{B777622E-E45F-4AE1-8403-CF0321523C31}"/>
               </a:ext>
             </a:extLst>
           </p:cNvPr>
@@ -9565,7 +9565,7 @@
           <p:cNvPr id="7" name="">
             <a:extLst xmlns:a="http://schemas.openxmlformats.org/drawingml/2006/main">
               <a:ext uri="{FF2B5EF4-FFF2-40B4-BE49-F238E27FC236}">
-                <a16:creationId xmlns:a16="http://schemas.microsoft.com/office/drawing/2014/main" id="{26954574-3645-4755-AAE5-7D874AF3DD1F}"/>
+                <a16:creationId xmlns:a16="http://schemas.microsoft.com/office/drawing/2014/main" id="{4404D796-C64F-487D-8FAE-800BE79F6ABC}"/>
               </a:ext>
             </a:extLst>
           </p:cNvPr>
@@ -9656,7 +9656,7 @@
           <p:cNvPr id="8" name="">
             <a:extLst xmlns:a="http://schemas.openxmlformats.org/drawingml/2006/main">
               <a:ext uri="{FF2B5EF4-FFF2-40B4-BE49-F238E27FC236}">
-                <a16:creationId xmlns:a16="http://schemas.microsoft.com/office/drawing/2014/main" id="{1F8D2E04-7C16-4571-AAA6-5E974E47C4CF}"/>
+                <a16:creationId xmlns:a16="http://schemas.microsoft.com/office/drawing/2014/main" id="{2A52D79F-00B1-4402-BB93-B8530B2C6DA5}"/>
               </a:ext>
             </a:extLst>
           </p:cNvPr>
@@ -9722,7 +9722,7 @@
     </p:spTree>
     <p:extLst>
       <p:ext uri="{BB962C8B-B14F-4D97-AF65-F5344CB8AC3E}">
-        <p14:creationId xmlns:p14="http://schemas.microsoft.com/office/powerpoint/2010/main" val="1520962808"/>
+        <p14:creationId xmlns:p14="http://schemas.microsoft.com/office/powerpoint/2010/main" val="1600082255"/>
       </p:ext>
     </p:extLst>
   </p:cSld>
@@ -9753,7 +9753,7 @@
           <p:cNvPr id="11" name="">
             <a:extLst xmlns:a="http://schemas.openxmlformats.org/drawingml/2006/main">
               <a:ext uri="{FF2B5EF4-FFF2-40B4-BE49-F238E27FC236}">
-                <a16:creationId xmlns:a16="http://schemas.microsoft.com/office/drawing/2014/main" id="{98E53019-054F-4AC5-9677-2E9B00E1D23C}"/>
+                <a16:creationId xmlns:a16="http://schemas.microsoft.com/office/drawing/2014/main" id="{988703BE-8C54-49D0-886C-27C123CDBEEE}"/>
               </a:ext>
             </a:extLst>
           </p:cNvPr>
@@ -9821,7 +9821,7 @@
           <p:cNvPr id="2" name="">
             <a:extLst xmlns:a="http://schemas.openxmlformats.org/drawingml/2006/main">
               <a:ext uri="{FF2B5EF4-FFF2-40B4-BE49-F238E27FC236}">
-                <a16:creationId xmlns:a16="http://schemas.microsoft.com/office/drawing/2014/main" id="{CADDD5DF-56BD-450B-9933-F040474C79C3}"/>
+                <a16:creationId xmlns:a16="http://schemas.microsoft.com/office/drawing/2014/main" id="{3D357762-9A56-4663-B8B8-AC97F98439C6}"/>
               </a:ext>
             </a:extLst>
           </p:cNvPr>
@@ -9889,7 +9889,7 @@
           <p:cNvPr id="3" name="">
             <a:extLst xmlns:a="http://schemas.openxmlformats.org/drawingml/2006/main">
               <a:ext uri="{FF2B5EF4-FFF2-40B4-BE49-F238E27FC236}">
-                <a16:creationId xmlns:a16="http://schemas.microsoft.com/office/drawing/2014/main" id="{4C4B52AE-A5A8-4480-B86A-426C1DEBF0A7}"/>
+                <a16:creationId xmlns:a16="http://schemas.microsoft.com/office/drawing/2014/main" id="{61C2CE37-161B-4D50-9F70-8CB195EFBD60}"/>
               </a:ext>
             </a:extLst>
           </p:cNvPr>
@@ -9899,7 +9899,7 @@
           <p:nvPr/>
         </p:nvPicPr>
         <p:blipFill>
-          <a:blip xmlns:r="http://schemas.openxmlformats.org/officeDocument/2006/relationships" xmlns:a="http://schemas.openxmlformats.org/drawingml/2006/main" r:embed="R2ed54865c3e34620"/>
+          <a:blip xmlns:r="http://schemas.openxmlformats.org/officeDocument/2006/relationships" xmlns:a="http://schemas.openxmlformats.org/drawingml/2006/main" r:embed="Rb50a14eba29440af"/>
           <a:stretch xmlns:a="http://schemas.openxmlformats.org/drawingml/2006/main"/>
         </p:blipFill>
         <p:spPr>
@@ -9917,7 +9917,7 @@
           <p:cNvPr id="4" name="">
             <a:extLst xmlns:a="http://schemas.openxmlformats.org/drawingml/2006/main">
               <a:ext uri="{FF2B5EF4-FFF2-40B4-BE49-F238E27FC236}">
-                <a16:creationId xmlns:a16="http://schemas.microsoft.com/office/drawing/2014/main" id="{E3167601-9A5D-453A-A670-A7138ED5A955}"/>
+                <a16:creationId xmlns:a16="http://schemas.microsoft.com/office/drawing/2014/main" id="{91C38C0B-5E4F-41CD-9FC8-5373293E157B}"/>
               </a:ext>
             </a:extLst>
           </p:cNvPr>
@@ -9985,7 +9985,7 @@
           <p:cNvPr id="5" name="">
             <a:extLst xmlns:a="http://schemas.openxmlformats.org/drawingml/2006/main">
               <a:ext uri="{FF2B5EF4-FFF2-40B4-BE49-F238E27FC236}">
-                <a16:creationId xmlns:a16="http://schemas.microsoft.com/office/drawing/2014/main" id="{4721366A-8DFB-4BD3-A107-A0A1AD47D867}"/>
+                <a16:creationId xmlns:a16="http://schemas.microsoft.com/office/drawing/2014/main" id="{73114A42-3173-4222-A210-96020E3DAB03}"/>
               </a:ext>
             </a:extLst>
           </p:cNvPr>
@@ -10076,7 +10076,7 @@
           <p:cNvPr id="6" name="">
             <a:extLst xmlns:a="http://schemas.openxmlformats.org/drawingml/2006/main">
               <a:ext uri="{FF2B5EF4-FFF2-40B4-BE49-F238E27FC236}">
-                <a16:creationId xmlns:a16="http://schemas.microsoft.com/office/drawing/2014/main" id="{C4059228-1834-4284-B258-8FBEC9EB06BF}"/>
+                <a16:creationId xmlns:a16="http://schemas.microsoft.com/office/drawing/2014/main" id="{4864EA06-061C-4724-A104-06D2DA1B2750}"/>
               </a:ext>
             </a:extLst>
           </p:cNvPr>
@@ -10144,7 +10144,7 @@
           <p:cNvPr id="7" name="">
             <a:extLst xmlns:a="http://schemas.openxmlformats.org/drawingml/2006/main">
               <a:ext uri="{FF2B5EF4-FFF2-40B4-BE49-F238E27FC236}">
-                <a16:creationId xmlns:a16="http://schemas.microsoft.com/office/drawing/2014/main" id="{2D0686F8-ABB9-44A1-BEF3-D5E70E9CB09E}"/>
+                <a16:creationId xmlns:a16="http://schemas.microsoft.com/office/drawing/2014/main" id="{C2927F96-C244-4540-A4DE-162DD0E95217}"/>
               </a:ext>
             </a:extLst>
           </p:cNvPr>
@@ -10235,7 +10235,7 @@
           <p:cNvPr id="8" name="">
             <a:extLst xmlns:a="http://schemas.openxmlformats.org/drawingml/2006/main">
               <a:ext uri="{FF2B5EF4-FFF2-40B4-BE49-F238E27FC236}">
-                <a16:creationId xmlns:a16="http://schemas.microsoft.com/office/drawing/2014/main" id="{51BEB915-0D39-4E70-99E5-506321F70F9B}"/>
+                <a16:creationId xmlns:a16="http://schemas.microsoft.com/office/drawing/2014/main" id="{41600412-4C05-4326-A263-E0580DEF1BFC}"/>
               </a:ext>
             </a:extLst>
           </p:cNvPr>
@@ -10303,7 +10303,7 @@
           <p:cNvPr id="9" name="">
             <a:extLst xmlns:a="http://schemas.openxmlformats.org/drawingml/2006/main">
               <a:ext uri="{FF2B5EF4-FFF2-40B4-BE49-F238E27FC236}">
-                <a16:creationId xmlns:a16="http://schemas.microsoft.com/office/drawing/2014/main" id="{2F87D8EB-DC3E-47A4-857D-41794A575C8E}"/>
+                <a16:creationId xmlns:a16="http://schemas.microsoft.com/office/drawing/2014/main" id="{1D508876-15BD-48EE-8534-146593619527}"/>
               </a:ext>
             </a:extLst>
           </p:cNvPr>
@@ -10394,7 +10394,7 @@
           <p:cNvPr id="10" name="">
             <a:extLst xmlns:a="http://schemas.openxmlformats.org/drawingml/2006/main">
               <a:ext uri="{FF2B5EF4-FFF2-40B4-BE49-F238E27FC236}">
-                <a16:creationId xmlns:a16="http://schemas.microsoft.com/office/drawing/2014/main" id="{7D4BA607-F172-4408-BD28-AB46D35B8226}"/>
+                <a16:creationId xmlns:a16="http://schemas.microsoft.com/office/drawing/2014/main" id="{C93881FF-7535-4246-B496-360956F525DD}"/>
               </a:ext>
             </a:extLst>
           </p:cNvPr>
@@ -10460,7 +10460,7 @@
     </p:spTree>
     <p:extLst>
       <p:ext uri="{BB962C8B-B14F-4D97-AF65-F5344CB8AC3E}">
-        <p14:creationId xmlns:p14="http://schemas.microsoft.com/office/powerpoint/2010/main" val="477613350"/>
+        <p14:creationId xmlns:p14="http://schemas.microsoft.com/office/powerpoint/2010/main" val="785503167"/>
       </p:ext>
     </p:extLst>
   </p:cSld>
@@ -10491,7 +10491,7 @@
           <p:cNvPr id="7" name="">
             <a:extLst xmlns:a="http://schemas.openxmlformats.org/drawingml/2006/main">
               <a:ext uri="{FF2B5EF4-FFF2-40B4-BE49-F238E27FC236}">
-                <a16:creationId xmlns:a16="http://schemas.microsoft.com/office/drawing/2014/main" id="{3E66EBF2-0F1F-4BC7-A900-FAC281359892}"/>
+                <a16:creationId xmlns:a16="http://schemas.microsoft.com/office/drawing/2014/main" id="{E39CA454-DB0E-4B00-954A-A57ABD649F59}"/>
               </a:ext>
             </a:extLst>
           </p:cNvPr>
@@ -10559,7 +10559,7 @@
           <p:cNvPr id="2" name="">
             <a:extLst xmlns:a="http://schemas.openxmlformats.org/drawingml/2006/main">
               <a:ext uri="{FF2B5EF4-FFF2-40B4-BE49-F238E27FC236}">
-                <a16:creationId xmlns:a16="http://schemas.microsoft.com/office/drawing/2014/main" id="{07F7E412-BB5C-490D-BAFE-C4489E8726C7}"/>
+                <a16:creationId xmlns:a16="http://schemas.microsoft.com/office/drawing/2014/main" id="{2FCAA0FD-BF82-42C3-9E18-8E359D3BFA55}"/>
               </a:ext>
             </a:extLst>
           </p:cNvPr>
@@ -10627,7 +10627,7 @@
           <p:cNvPr id="3" name="">
             <a:extLst xmlns:a="http://schemas.openxmlformats.org/drawingml/2006/main">
               <a:ext uri="{FF2B5EF4-FFF2-40B4-BE49-F238E27FC236}">
-                <a16:creationId xmlns:a16="http://schemas.microsoft.com/office/drawing/2014/main" id="{39A067F7-BD68-4AA6-8E0D-2ADD53FC5707}"/>
+                <a16:creationId xmlns:a16="http://schemas.microsoft.com/office/drawing/2014/main" id="{2E4F22A1-4D7D-429D-A5C9-C66808BAB8D9}"/>
               </a:ext>
             </a:extLst>
           </p:cNvPr>
@@ -10695,7 +10695,7 @@
           <p:cNvPr id="4" name="">
             <a:extLst xmlns:a="http://schemas.openxmlformats.org/drawingml/2006/main">
               <a:ext uri="{FF2B5EF4-FFF2-40B4-BE49-F238E27FC236}">
-                <a16:creationId xmlns:a16="http://schemas.microsoft.com/office/drawing/2014/main" id="{D77B1270-E279-4E16-98BD-477C4B181C81}"/>
+                <a16:creationId xmlns:a16="http://schemas.microsoft.com/office/drawing/2014/main" id="{63C38D1E-CE1F-46A3-BD62-1254D6BF1232}"/>
               </a:ext>
             </a:extLst>
           </p:cNvPr>
@@ -10786,7 +10786,7 @@
           <p:cNvPr id="5" name="">
             <a:extLst xmlns:a="http://schemas.openxmlformats.org/drawingml/2006/main">
               <a:ext uri="{FF2B5EF4-FFF2-40B4-BE49-F238E27FC236}">
-                <a16:creationId xmlns:a16="http://schemas.microsoft.com/office/drawing/2014/main" id="{8B9508F1-8590-476D-8FA5-1E92B5231A45}"/>
+                <a16:creationId xmlns:a16="http://schemas.microsoft.com/office/drawing/2014/main" id="{594C7602-0737-474D-B810-ECF849BF3453}"/>
               </a:ext>
             </a:extLst>
           </p:cNvPr>
@@ -10854,7 +10854,7 @@
           <p:cNvPr id="6" name="">
             <a:extLst xmlns:a="http://schemas.openxmlformats.org/drawingml/2006/main">
               <a:ext uri="{FF2B5EF4-FFF2-40B4-BE49-F238E27FC236}">
-                <a16:creationId xmlns:a16="http://schemas.microsoft.com/office/drawing/2014/main" id="{12BD967F-718E-484F-BA25-F4CF95D149E2}"/>
+                <a16:creationId xmlns:a16="http://schemas.microsoft.com/office/drawing/2014/main" id="{F7299D5F-B47E-442F-A08D-03298F576125}"/>
               </a:ext>
             </a:extLst>
           </p:cNvPr>
@@ -10966,7 +10966,7 @@
     </p:spTree>
     <p:extLst>
       <p:ext uri="{BB962C8B-B14F-4D97-AF65-F5344CB8AC3E}">
-        <p14:creationId xmlns:p14="http://schemas.microsoft.com/office/powerpoint/2010/main" val="648807872"/>
+        <p14:creationId xmlns:p14="http://schemas.microsoft.com/office/powerpoint/2010/main" val="1049213853"/>
       </p:ext>
     </p:extLst>
   </p:cSld>
@@ -10997,7 +10997,7 @@
           <p:cNvPr id="8" name="">
             <a:extLst xmlns:a="http://schemas.openxmlformats.org/drawingml/2006/main">
               <a:ext uri="{FF2B5EF4-FFF2-40B4-BE49-F238E27FC236}">
-                <a16:creationId xmlns:a16="http://schemas.microsoft.com/office/drawing/2014/main" id="{532CCF00-2EF1-4CC2-BF5B-8B25B314D346}"/>
+                <a16:creationId xmlns:a16="http://schemas.microsoft.com/office/drawing/2014/main" id="{324B988E-987C-48C5-B629-15EA61FBF3DD}"/>
               </a:ext>
             </a:extLst>
           </p:cNvPr>
@@ -11065,7 +11065,7 @@
           <p:cNvPr id="2" name="">
             <a:extLst xmlns:a="http://schemas.openxmlformats.org/drawingml/2006/main">
               <a:ext uri="{FF2B5EF4-FFF2-40B4-BE49-F238E27FC236}">
-                <a16:creationId xmlns:a16="http://schemas.microsoft.com/office/drawing/2014/main" id="{5BB174C0-28F3-4D73-860F-3E0828A731F6}"/>
+                <a16:creationId xmlns:a16="http://schemas.microsoft.com/office/drawing/2014/main" id="{1A1B8EDE-30EA-4A63-935B-A7B66F1215FF}"/>
               </a:ext>
             </a:extLst>
           </p:cNvPr>
@@ -11133,7 +11133,7 @@
           <p:cNvPr id="3" name="">
             <a:extLst xmlns:a="http://schemas.openxmlformats.org/drawingml/2006/main">
               <a:ext uri="{FF2B5EF4-FFF2-40B4-BE49-F238E27FC236}">
-                <a16:creationId xmlns:a16="http://schemas.microsoft.com/office/drawing/2014/main" id="{69C25EA4-2B65-4B5B-8602-5B6048CFCD19}"/>
+                <a16:creationId xmlns:a16="http://schemas.microsoft.com/office/drawing/2014/main" id="{1640B778-2293-406C-83B2-6F7157CCE4FB}"/>
               </a:ext>
             </a:extLst>
           </p:cNvPr>
@@ -11201,7 +11201,7 @@
           <p:cNvPr id="4" name="">
             <a:extLst xmlns:a="http://schemas.openxmlformats.org/drawingml/2006/main">
               <a:ext uri="{FF2B5EF4-FFF2-40B4-BE49-F238E27FC236}">
-                <a16:creationId xmlns:a16="http://schemas.microsoft.com/office/drawing/2014/main" id="{8AAC376D-30EC-482B-99E3-929EFF851A3C}"/>
+                <a16:creationId xmlns:a16="http://schemas.microsoft.com/office/drawing/2014/main" id="{03562F78-BB22-42B0-A203-75E3DD0DA40A}"/>
               </a:ext>
             </a:extLst>
           </p:cNvPr>
@@ -11371,7 +11371,7 @@
           <p:cNvPr id="5" name="">
             <a:extLst xmlns:a="http://schemas.openxmlformats.org/drawingml/2006/main">
               <a:ext uri="{FF2B5EF4-FFF2-40B4-BE49-F238E27FC236}">
-                <a16:creationId xmlns:a16="http://schemas.microsoft.com/office/drawing/2014/main" id="{E297C6D4-DA7C-461D-B0A0-9F1DC4F9F407}"/>
+                <a16:creationId xmlns:a16="http://schemas.microsoft.com/office/drawing/2014/main" id="{EB7245E7-4E57-4EC6-A169-E3BD9A4FAE91}"/>
               </a:ext>
             </a:extLst>
           </p:cNvPr>
@@ -11439,7 +11439,7 @@
           <p:cNvPr id="6" name="">
             <a:extLst xmlns:a="http://schemas.openxmlformats.org/drawingml/2006/main">
               <a:ext uri="{FF2B5EF4-FFF2-40B4-BE49-F238E27FC236}">
-                <a16:creationId xmlns:a16="http://schemas.microsoft.com/office/drawing/2014/main" id="{DDED1982-3F4A-4690-91D5-8F4F3C4B2279}"/>
+                <a16:creationId xmlns:a16="http://schemas.microsoft.com/office/drawing/2014/main" id="{72733EED-1B7B-466F-A888-93F2E7A6D868}"/>
               </a:ext>
             </a:extLst>
           </p:cNvPr>
@@ -11530,7 +11530,7 @@
           <p:cNvPr id="7" name="">
             <a:extLst xmlns:a="http://schemas.openxmlformats.org/drawingml/2006/main">
               <a:ext uri="{FF2B5EF4-FFF2-40B4-BE49-F238E27FC236}">
-                <a16:creationId xmlns:a16="http://schemas.microsoft.com/office/drawing/2014/main" id="{73B69DD6-11AD-4376-9242-E3A519EADAA5}"/>
+                <a16:creationId xmlns:a16="http://schemas.microsoft.com/office/drawing/2014/main" id="{18444E2D-732A-4C73-8008-C6ABC467167B}"/>
               </a:ext>
             </a:extLst>
           </p:cNvPr>
@@ -11642,7 +11642,7 @@
     </p:spTree>
     <p:extLst>
       <p:ext uri="{BB962C8B-B14F-4D97-AF65-F5344CB8AC3E}">
-        <p14:creationId xmlns:p14="http://schemas.microsoft.com/office/powerpoint/2010/main" val="1954845083"/>
+        <p14:creationId xmlns:p14="http://schemas.microsoft.com/office/powerpoint/2010/main" val="162436659"/>
       </p:ext>
     </p:extLst>
   </p:cSld>
@@ -11673,7 +11673,7 @@
           <p:cNvPr id="9" name="">
             <a:extLst xmlns:a="http://schemas.openxmlformats.org/drawingml/2006/main">
               <a:ext uri="{FF2B5EF4-FFF2-40B4-BE49-F238E27FC236}">
-                <a16:creationId xmlns:a16="http://schemas.microsoft.com/office/drawing/2014/main" id="{A2EE9706-B24C-417D-811E-C60C9B9FE0E9}"/>
+                <a16:creationId xmlns:a16="http://schemas.microsoft.com/office/drawing/2014/main" id="{CB45FBF9-FC39-4FE9-9675-249F59B5802E}"/>
               </a:ext>
             </a:extLst>
           </p:cNvPr>
@@ -11741,7 +11741,7 @@
           <p:cNvPr id="2" name="">
             <a:extLst xmlns:a="http://schemas.openxmlformats.org/drawingml/2006/main">
               <a:ext uri="{FF2B5EF4-FFF2-40B4-BE49-F238E27FC236}">
-                <a16:creationId xmlns:a16="http://schemas.microsoft.com/office/drawing/2014/main" id="{3137EB12-F92E-4097-8421-6D883A26E70B}"/>
+                <a16:creationId xmlns:a16="http://schemas.microsoft.com/office/drawing/2014/main" id="{FEDA2958-2208-4889-BE05-7C6001C638D8}"/>
               </a:ext>
             </a:extLst>
           </p:cNvPr>
@@ -11809,7 +11809,7 @@
           <p:cNvPr id="3" name="">
             <a:extLst xmlns:a="http://schemas.openxmlformats.org/drawingml/2006/main">
               <a:ext uri="{FF2B5EF4-FFF2-40B4-BE49-F238E27FC236}">
-                <a16:creationId xmlns:a16="http://schemas.microsoft.com/office/drawing/2014/main" id="{81DEF2FC-5338-4EAF-937E-B0C9AECD6CA4}"/>
+                <a16:creationId xmlns:a16="http://schemas.microsoft.com/office/drawing/2014/main" id="{8FA9A086-B9EE-43A7-8380-687A6F8CC81A}"/>
               </a:ext>
             </a:extLst>
           </p:cNvPr>
@@ -11877,7 +11877,7 @@
           <p:cNvPr id="4" name="">
             <a:extLst xmlns:a="http://schemas.openxmlformats.org/drawingml/2006/main">
               <a:ext uri="{FF2B5EF4-FFF2-40B4-BE49-F238E27FC236}">
-                <a16:creationId xmlns:a16="http://schemas.microsoft.com/office/drawing/2014/main" id="{90D38AC0-13F9-479A-98D0-340E1BDB4027}"/>
+                <a16:creationId xmlns:a16="http://schemas.microsoft.com/office/drawing/2014/main" id="{0D8C8C21-2626-4E23-86D4-5BAE74A50237}"/>
               </a:ext>
             </a:extLst>
           </p:cNvPr>
@@ -11968,7 +11968,7 @@
           <p:cNvPr id="5" name="">
             <a:extLst xmlns:a="http://schemas.openxmlformats.org/drawingml/2006/main">
               <a:ext uri="{FF2B5EF4-FFF2-40B4-BE49-F238E27FC236}">
-                <a16:creationId xmlns:a16="http://schemas.microsoft.com/office/drawing/2014/main" id="{E9A46ECF-18EE-4F7E-88F3-9DF6868C0DF9}"/>
+                <a16:creationId xmlns:a16="http://schemas.microsoft.com/office/drawing/2014/main" id="{DF77AAA9-87E3-436F-8349-FA717E512006}"/>
               </a:ext>
             </a:extLst>
           </p:cNvPr>
@@ -12036,7 +12036,7 @@
           <p:cNvPr id="6" name="">
             <a:extLst xmlns:a="http://schemas.openxmlformats.org/drawingml/2006/main">
               <a:ext uri="{FF2B5EF4-FFF2-40B4-BE49-F238E27FC236}">
-                <a16:creationId xmlns:a16="http://schemas.microsoft.com/office/drawing/2014/main" id="{798372C5-5266-4A81-B26F-D8C1D60AE9CD}"/>
+                <a16:creationId xmlns:a16="http://schemas.microsoft.com/office/drawing/2014/main" id="{AF11B07C-745A-4CB9-BF72-5FDCA782C77B}"/>
               </a:ext>
             </a:extLst>
           </p:cNvPr>
@@ -12104,7 +12104,7 @@
           <p:cNvPr id="7" name="Chart">
             <a:extLst xmlns:a="http://schemas.openxmlformats.org/drawingml/2006/main">
               <a:ext uri="{FF2B5EF4-FFF2-40B4-BE49-F238E27FC236}">
-                <a16:creationId xmlns:a16="http://schemas.microsoft.com/office/drawing/2014/main" id="{B75E6D02-7100-4DCD-9C57-E71053DF8FE1}"/>
+                <a16:creationId xmlns:a16="http://schemas.microsoft.com/office/drawing/2014/main" id="{D6C1F461-8769-4467-A0D1-AFE0E36C61ED}"/>
               </a:ext>
             </a:extLst>
           </p:cNvPr>
@@ -12117,7 +12117,7 @@
         </p:xfrm>
         <a:graphic xmlns:a="http://schemas.openxmlformats.org/drawingml/2006/main">
           <a:graphicData uri="http://schemas.openxmlformats.org/drawingml/2006/chart">
-            <c:chart xmlns:r="http://schemas.openxmlformats.org/officeDocument/2006/relationships" xmlns:c="http://schemas.openxmlformats.org/drawingml/2006/chart" r:id="R60be8e89f2b447d2"/>
+            <c:chart xmlns:r="http://schemas.openxmlformats.org/officeDocument/2006/relationships" xmlns:c="http://schemas.openxmlformats.org/drawingml/2006/chart" r:id="R5be7bf6fd10947b9"/>
           </a:graphicData>
         </a:graphic>
       </p:graphicFrame>
@@ -12126,7 +12126,7 @@
           <p:cNvPr id="8" name="">
             <a:extLst xmlns:a="http://schemas.openxmlformats.org/drawingml/2006/main">
               <a:ext uri="{FF2B5EF4-FFF2-40B4-BE49-F238E27FC236}">
-                <a16:creationId xmlns:a16="http://schemas.microsoft.com/office/drawing/2014/main" id="{1B369293-B77D-4B69-B14F-1E6093EB5D6D}"/>
+                <a16:creationId xmlns:a16="http://schemas.microsoft.com/office/drawing/2014/main" id="{61ADA323-D60C-4131-B947-F1832A3CEBF2}"/>
               </a:ext>
             </a:extLst>
           </p:cNvPr>
@@ -12192,7 +12192,7 @@
     </p:spTree>
     <p:extLst>
       <p:ext uri="{BB962C8B-B14F-4D97-AF65-F5344CB8AC3E}">
-        <p14:creationId xmlns:p14="http://schemas.microsoft.com/office/powerpoint/2010/main" val="1121045169"/>
+        <p14:creationId xmlns:p14="http://schemas.microsoft.com/office/powerpoint/2010/main" val="76253674"/>
       </p:ext>
     </p:extLst>
   </p:cSld>
@@ -12223,7 +12223,7 @@
           <p:cNvPr id="5" name="">
             <a:extLst xmlns:a="http://schemas.openxmlformats.org/drawingml/2006/main">
               <a:ext uri="{FF2B5EF4-FFF2-40B4-BE49-F238E27FC236}">
-                <a16:creationId xmlns:a16="http://schemas.microsoft.com/office/drawing/2014/main" id="{9E229FCF-E3AF-424D-8EF2-0ED36F824D01}"/>
+                <a16:creationId xmlns:a16="http://schemas.microsoft.com/office/drawing/2014/main" id="{2D5F54EE-D2EC-4CB6-A9E8-5F23FB730A09}"/>
               </a:ext>
             </a:extLst>
           </p:cNvPr>
@@ -12291,7 +12291,7 @@
           <p:cNvPr id="2" name="">
             <a:extLst xmlns:a="http://schemas.openxmlformats.org/drawingml/2006/main">
               <a:ext uri="{FF2B5EF4-FFF2-40B4-BE49-F238E27FC236}">
-                <a16:creationId xmlns:a16="http://schemas.microsoft.com/office/drawing/2014/main" id="{0CA183BC-DC1A-4728-B81E-13C6CB54BC3C}"/>
+                <a16:creationId xmlns:a16="http://schemas.microsoft.com/office/drawing/2014/main" id="{9B321EE8-DAB1-4A36-AB01-C7C7F588133E}"/>
               </a:ext>
             </a:extLst>
           </p:cNvPr>
@@ -12359,7 +12359,7 @@
           <p:cNvPr id="3" name="">
             <a:extLst xmlns:a="http://schemas.openxmlformats.org/drawingml/2006/main">
               <a:ext uri="{FF2B5EF4-FFF2-40B4-BE49-F238E27FC236}">
-                <a16:creationId xmlns:a16="http://schemas.microsoft.com/office/drawing/2014/main" id="{98321708-E967-4BCC-8705-F32E7C608B2B}"/>
+                <a16:creationId xmlns:a16="http://schemas.microsoft.com/office/drawing/2014/main" id="{DECD33E9-1F57-49D4-81BB-934ACEEF29D4}"/>
               </a:ext>
             </a:extLst>
           </p:cNvPr>
@@ -12687,7 +12687,7 @@
           <p:cNvPr id="4" name="">
             <a:extLst xmlns:a="http://schemas.openxmlformats.org/drawingml/2006/main">
               <a:ext uri="{FF2B5EF4-FFF2-40B4-BE49-F238E27FC236}">
-                <a16:creationId xmlns:a16="http://schemas.microsoft.com/office/drawing/2014/main" id="{2D359BE3-D726-42D6-84A2-71C1FFC850EF}"/>
+                <a16:creationId xmlns:a16="http://schemas.microsoft.com/office/drawing/2014/main" id="{DCCF9A70-3835-455B-973C-4D90E1A9075F}"/>
               </a:ext>
             </a:extLst>
           </p:cNvPr>
@@ -12776,7 +12776,7 @@
     </p:spTree>
     <p:extLst>
       <p:ext uri="{BB962C8B-B14F-4D97-AF65-F5344CB8AC3E}">
-        <p14:creationId xmlns:p14="http://schemas.microsoft.com/office/powerpoint/2010/main" val="246421115"/>
+        <p14:creationId xmlns:p14="http://schemas.microsoft.com/office/powerpoint/2010/main" val="2073217587"/>
       </p:ext>
     </p:extLst>
   </p:cSld>
@@ -12807,7 +12807,7 @@
           <p:cNvPr id="9" name="">
             <a:extLst xmlns:a="http://schemas.openxmlformats.org/drawingml/2006/main">
               <a:ext uri="{FF2B5EF4-FFF2-40B4-BE49-F238E27FC236}">
-                <a16:creationId xmlns:a16="http://schemas.microsoft.com/office/drawing/2014/main" id="{8AD803BF-8D22-4284-9169-2071931612CD}"/>
+                <a16:creationId xmlns:a16="http://schemas.microsoft.com/office/drawing/2014/main" id="{ED30CDF3-9893-4977-8B57-5C3B97732A6C}"/>
               </a:ext>
             </a:extLst>
           </p:cNvPr>
@@ -12875,7 +12875,7 @@
           <p:cNvPr id="2" name="">
             <a:extLst xmlns:a="http://schemas.openxmlformats.org/drawingml/2006/main">
               <a:ext uri="{FF2B5EF4-FFF2-40B4-BE49-F238E27FC236}">
-                <a16:creationId xmlns:a16="http://schemas.microsoft.com/office/drawing/2014/main" id="{05B325F6-91A3-4369-B9D6-81E572EC6274}"/>
+                <a16:creationId xmlns:a16="http://schemas.microsoft.com/office/drawing/2014/main" id="{D0C7136A-AB2B-44C1-8225-AFB50099378B}"/>
               </a:ext>
             </a:extLst>
           </p:cNvPr>
@@ -12943,7 +12943,7 @@
           <p:cNvPr id="3" name="">
             <a:extLst xmlns:a="http://schemas.openxmlformats.org/drawingml/2006/main">
               <a:ext uri="{FF2B5EF4-FFF2-40B4-BE49-F238E27FC236}">
-                <a16:creationId xmlns:a16="http://schemas.microsoft.com/office/drawing/2014/main" id="{645EFEC1-6DF9-4F1B-B09E-8D8FC178607C}"/>
+                <a16:creationId xmlns:a16="http://schemas.microsoft.com/office/drawing/2014/main" id="{62DAA61C-1071-4F9A-ACE7-08CF42C331A1}"/>
               </a:ext>
             </a:extLst>
           </p:cNvPr>
@@ -13011,7 +13011,7 @@
           <p:cNvPr id="4" name="">
             <a:extLst xmlns:a="http://schemas.openxmlformats.org/drawingml/2006/main">
               <a:ext uri="{FF2B5EF4-FFF2-40B4-BE49-F238E27FC236}">
-                <a16:creationId xmlns:a16="http://schemas.microsoft.com/office/drawing/2014/main" id="{24708866-E829-4794-80CD-BC28B899DCD0}"/>
+                <a16:creationId xmlns:a16="http://schemas.microsoft.com/office/drawing/2014/main" id="{7651BDFE-ADD5-485B-912D-7A5C79CBB7BC}"/>
               </a:ext>
             </a:extLst>
           </p:cNvPr>
@@ -13079,7 +13079,7 @@
           <p:cNvPr id="5" name="">
             <a:extLst xmlns:a="http://schemas.openxmlformats.org/drawingml/2006/main">
               <a:ext uri="{FF2B5EF4-FFF2-40B4-BE49-F238E27FC236}">
-                <a16:creationId xmlns:a16="http://schemas.microsoft.com/office/drawing/2014/main" id="{C1930FA0-EEE2-4B90-9BAC-BEBDE16DCC53}"/>
+                <a16:creationId xmlns:a16="http://schemas.microsoft.com/office/drawing/2014/main" id="{B0C6F754-FE77-4FF6-B92D-DDA375EAFF15}"/>
               </a:ext>
             </a:extLst>
           </p:cNvPr>
@@ -13147,7 +13147,7 @@
           <p:cNvPr id="6" name="">
             <a:extLst xmlns:a="http://schemas.openxmlformats.org/drawingml/2006/main">
               <a:ext uri="{FF2B5EF4-FFF2-40B4-BE49-F238E27FC236}">
-                <a16:creationId xmlns:a16="http://schemas.microsoft.com/office/drawing/2014/main" id="{ABBEA379-4CC9-48DD-B2B2-49A102FD4E59}"/>
+                <a16:creationId xmlns:a16="http://schemas.microsoft.com/office/drawing/2014/main" id="{55F6E0F9-98ED-49F1-B121-4ED0953D6F9A}"/>
               </a:ext>
             </a:extLst>
           </p:cNvPr>
@@ -13215,7 +13215,7 @@
           <p:cNvPr id="7" name="">
             <a:extLst xmlns:a="http://schemas.openxmlformats.org/drawingml/2006/main">
               <a:ext uri="{FF2B5EF4-FFF2-40B4-BE49-F238E27FC236}">
-                <a16:creationId xmlns:a16="http://schemas.microsoft.com/office/drawing/2014/main" id="{BB46D6C6-E7AA-4977-9317-54FE770ADB8D}"/>
+                <a16:creationId xmlns:a16="http://schemas.microsoft.com/office/drawing/2014/main" id="{C691E55D-A7E2-4CB0-B1BA-EF7E06D5834F}"/>
               </a:ext>
             </a:extLst>
           </p:cNvPr>
@@ -13443,7 +13443,7 @@
           <p:cNvPr id="8" name="">
             <a:extLst xmlns:a="http://schemas.openxmlformats.org/drawingml/2006/main">
               <a:ext uri="{FF2B5EF4-FFF2-40B4-BE49-F238E27FC236}">
-                <a16:creationId xmlns:a16="http://schemas.microsoft.com/office/drawing/2014/main" id="{9EC9948C-14FE-44D9-8FF5-5F6F9BA8F936}"/>
+                <a16:creationId xmlns:a16="http://schemas.microsoft.com/office/drawing/2014/main" id="{B1F6EF19-C1D9-4391-A648-6A01EBA3A8E3}"/>
               </a:ext>
             </a:extLst>
           </p:cNvPr>
@@ -13509,7 +13509,7 @@
     </p:spTree>
     <p:extLst>
       <p:ext uri="{BB962C8B-B14F-4D97-AF65-F5344CB8AC3E}">
-        <p14:creationId xmlns:p14="http://schemas.microsoft.com/office/powerpoint/2010/main" val="1192256790"/>
+        <p14:creationId xmlns:p14="http://schemas.microsoft.com/office/powerpoint/2010/main" val="1306636645"/>
       </p:ext>
     </p:extLst>
   </p:cSld>
@@ -13540,7 +13540,7 @@
           <p:cNvPr id="5" name="">
             <a:extLst xmlns:a="http://schemas.openxmlformats.org/drawingml/2006/main">
               <a:ext uri="{FF2B5EF4-FFF2-40B4-BE49-F238E27FC236}">
-                <a16:creationId xmlns:a16="http://schemas.microsoft.com/office/drawing/2014/main" id="{926BFD3F-866F-48DA-B276-8635E225C6C8}"/>
+                <a16:creationId xmlns:a16="http://schemas.microsoft.com/office/drawing/2014/main" id="{36C51570-272B-47B3-B8E9-755BB085DEC4}"/>
               </a:ext>
             </a:extLst>
           </p:cNvPr>
@@ -13608,7 +13608,7 @@
           <p:cNvPr id="2" name="">
             <a:extLst xmlns:a="http://schemas.openxmlformats.org/drawingml/2006/main">
               <a:ext uri="{FF2B5EF4-FFF2-40B4-BE49-F238E27FC236}">
-                <a16:creationId xmlns:a16="http://schemas.microsoft.com/office/drawing/2014/main" id="{98DCF97E-0990-465E-92B5-CF03CB211E51}"/>
+                <a16:creationId xmlns:a16="http://schemas.microsoft.com/office/drawing/2014/main" id="{2EC78568-EA66-4763-94DE-050819031152}"/>
               </a:ext>
             </a:extLst>
           </p:cNvPr>
@@ -13676,7 +13676,7 @@
           <p:cNvPr id="3" name="">
             <a:extLst xmlns:a="http://schemas.openxmlformats.org/drawingml/2006/main">
               <a:ext uri="{FF2B5EF4-FFF2-40B4-BE49-F238E27FC236}">
-                <a16:creationId xmlns:a16="http://schemas.microsoft.com/office/drawing/2014/main" id="{2EDEB0EA-A2D3-4641-A3D8-FF8EF97CA571}"/>
+                <a16:creationId xmlns:a16="http://schemas.microsoft.com/office/drawing/2014/main" id="{EDA1C5CF-CFFE-4082-87B2-A9B95B00B794}"/>
               </a:ext>
             </a:extLst>
           </p:cNvPr>
@@ -14054,7 +14054,7 @@
           <p:cNvPr id="4" name="">
             <a:extLst xmlns:a="http://schemas.openxmlformats.org/drawingml/2006/main">
               <a:ext uri="{FF2B5EF4-FFF2-40B4-BE49-F238E27FC236}">
-                <a16:creationId xmlns:a16="http://schemas.microsoft.com/office/drawing/2014/main" id="{2CB46806-6856-4E76-BA15-90B612322860}"/>
+                <a16:creationId xmlns:a16="http://schemas.microsoft.com/office/drawing/2014/main" id="{BE4B4F9D-43CE-43E7-9AED-F22B8A56BA7C}"/>
               </a:ext>
             </a:extLst>
           </p:cNvPr>
@@ -14120,7 +14120,7 @@
     </p:spTree>
     <p:extLst>
       <p:ext uri="{BB962C8B-B14F-4D97-AF65-F5344CB8AC3E}">
-        <p14:creationId xmlns:p14="http://schemas.microsoft.com/office/powerpoint/2010/main" val="601889492"/>
+        <p14:creationId xmlns:p14="http://schemas.microsoft.com/office/powerpoint/2010/main" val="1493426142"/>
       </p:ext>
     </p:extLst>
   </p:cSld>
@@ -14151,7 +14151,7 @@
           <p:cNvPr id="6" name="">
             <a:extLst xmlns:a="http://schemas.openxmlformats.org/drawingml/2006/main">
               <a:ext uri="{FF2B5EF4-FFF2-40B4-BE49-F238E27FC236}">
-                <a16:creationId xmlns:a16="http://schemas.microsoft.com/office/drawing/2014/main" id="{20DB6AC8-3BBC-4058-B851-FC88EC16E36B}"/>
+                <a16:creationId xmlns:a16="http://schemas.microsoft.com/office/drawing/2014/main" id="{E49AC3CF-7867-478B-ADB2-A76EABC3C8B6}"/>
               </a:ext>
             </a:extLst>
           </p:cNvPr>
@@ -14219,7 +14219,7 @@
           <p:cNvPr id="2" name="">
             <a:extLst xmlns:a="http://schemas.openxmlformats.org/drawingml/2006/main">
               <a:ext uri="{FF2B5EF4-FFF2-40B4-BE49-F238E27FC236}">
-                <a16:creationId xmlns:a16="http://schemas.microsoft.com/office/drawing/2014/main" id="{6094D1FD-30F6-4D1B-AF5C-426F1836856D}"/>
+                <a16:creationId xmlns:a16="http://schemas.microsoft.com/office/drawing/2014/main" id="{AD14F8F5-5FE1-4E77-BEBE-24BA3D4FA9D1}"/>
               </a:ext>
             </a:extLst>
           </p:cNvPr>
@@ -14287,7 +14287,7 @@
           <p:cNvPr id="3" name="">
             <a:extLst xmlns:a="http://schemas.openxmlformats.org/drawingml/2006/main">
               <a:ext uri="{FF2B5EF4-FFF2-40B4-BE49-F238E27FC236}">
-                <a16:creationId xmlns:a16="http://schemas.microsoft.com/office/drawing/2014/main" id="{99E8B0EB-F3DC-4C18-98D5-5BF4AEFB2ECE}"/>
+                <a16:creationId xmlns:a16="http://schemas.microsoft.com/office/drawing/2014/main" id="{7173CA89-2412-47AF-A731-3CAD6E4F6F95}"/>
               </a:ext>
             </a:extLst>
           </p:cNvPr>
@@ -14355,7 +14355,7 @@
           <p:cNvPr id="4" name="Chart">
             <a:extLst xmlns:a="http://schemas.openxmlformats.org/drawingml/2006/main">
               <a:ext uri="{FF2B5EF4-FFF2-40B4-BE49-F238E27FC236}">
-                <a16:creationId xmlns:a16="http://schemas.microsoft.com/office/drawing/2014/main" id="{6F841117-F308-4AF4-AB0F-3F9B8A319592}"/>
+                <a16:creationId xmlns:a16="http://schemas.microsoft.com/office/drawing/2014/main" id="{1D638DEE-3F54-40ED-85F7-BA7337C0D0AA}"/>
               </a:ext>
             </a:extLst>
           </p:cNvPr>
@@ -14368,7 +14368,7 @@
         </p:xfrm>
         <a:graphic xmlns:a="http://schemas.openxmlformats.org/drawingml/2006/main">
           <a:graphicData uri="http://schemas.openxmlformats.org/drawingml/2006/chart">
-            <c:chart xmlns:r="http://schemas.openxmlformats.org/officeDocument/2006/relationships" xmlns:c="http://schemas.openxmlformats.org/drawingml/2006/chart" r:id="Rc759ed88295f4bb7"/>
+            <c:chart xmlns:r="http://schemas.openxmlformats.org/officeDocument/2006/relationships" xmlns:c="http://schemas.openxmlformats.org/drawingml/2006/chart" r:id="R469f3455984e4a9f"/>
           </a:graphicData>
         </a:graphic>
       </p:graphicFrame>
@@ -14377,7 +14377,7 @@
           <p:cNvPr id="5" name="">
             <a:extLst xmlns:a="http://schemas.openxmlformats.org/drawingml/2006/main">
               <a:ext uri="{FF2B5EF4-FFF2-40B4-BE49-F238E27FC236}">
-                <a16:creationId xmlns:a16="http://schemas.microsoft.com/office/drawing/2014/main" id="{86A4B7E5-1981-4BAD-BD08-EAE3806F8883}"/>
+                <a16:creationId xmlns:a16="http://schemas.microsoft.com/office/drawing/2014/main" id="{5DCCE7F7-1460-448E-92D9-AB407A87878C}"/>
               </a:ext>
             </a:extLst>
           </p:cNvPr>
@@ -14443,7 +14443,7 @@
     </p:spTree>
     <p:extLst>
       <p:ext uri="{BB962C8B-B14F-4D97-AF65-F5344CB8AC3E}">
-        <p14:creationId xmlns:p14="http://schemas.microsoft.com/office/powerpoint/2010/main" val="224997587"/>
+        <p14:creationId xmlns:p14="http://schemas.microsoft.com/office/powerpoint/2010/main" val="1300200114"/>
       </p:ext>
     </p:extLst>
   </p:cSld>
@@ -14474,7 +14474,7 @@
           <p:cNvPr id="8" name="">
             <a:extLst xmlns:a="http://schemas.openxmlformats.org/drawingml/2006/main">
               <a:ext uri="{FF2B5EF4-FFF2-40B4-BE49-F238E27FC236}">
-                <a16:creationId xmlns:a16="http://schemas.microsoft.com/office/drawing/2014/main" id="{9CA7EB03-8005-4979-9217-0A52230C5438}"/>
+                <a16:creationId xmlns:a16="http://schemas.microsoft.com/office/drawing/2014/main" id="{53760A4E-FF8B-4EE1-8409-A20E1AF5E3F9}"/>
               </a:ext>
             </a:extLst>
           </p:cNvPr>
@@ -14542,7 +14542,7 @@
           <p:cNvPr id="2" name="">
             <a:extLst xmlns:a="http://schemas.openxmlformats.org/drawingml/2006/main">
               <a:ext uri="{FF2B5EF4-FFF2-40B4-BE49-F238E27FC236}">
-                <a16:creationId xmlns:a16="http://schemas.microsoft.com/office/drawing/2014/main" id="{FFEACC71-4EC7-4F50-BFCB-FA7C2B93843E}"/>
+                <a16:creationId xmlns:a16="http://schemas.microsoft.com/office/drawing/2014/main" id="{852B2194-0EE0-4D69-A53D-BCB027C1BD82}"/>
               </a:ext>
             </a:extLst>
           </p:cNvPr>
@@ -14610,7 +14610,7 @@
           <p:cNvPr id="3" name="Chart">
             <a:extLst xmlns:a="http://schemas.openxmlformats.org/drawingml/2006/main">
               <a:ext uri="{FF2B5EF4-FFF2-40B4-BE49-F238E27FC236}">
-                <a16:creationId xmlns:a16="http://schemas.microsoft.com/office/drawing/2014/main" id="{A498DB34-478C-48AF-8B82-9D0B8B2E8619}"/>
+                <a16:creationId xmlns:a16="http://schemas.microsoft.com/office/drawing/2014/main" id="{173D5921-788C-4811-AC29-3010EBF279C5}"/>
               </a:ext>
             </a:extLst>
           </p:cNvPr>
@@ -14623,7 +14623,7 @@
         </p:xfrm>
         <a:graphic xmlns:a="http://schemas.openxmlformats.org/drawingml/2006/main">
           <a:graphicData uri="http://schemas.openxmlformats.org/drawingml/2006/chart">
-            <c:chart xmlns:r="http://schemas.openxmlformats.org/officeDocument/2006/relationships" xmlns:c="http://schemas.openxmlformats.org/drawingml/2006/chart" r:id="Rf1d83628f3ef4b33"/>
+            <c:chart xmlns:r="http://schemas.openxmlformats.org/officeDocument/2006/relationships" xmlns:c="http://schemas.openxmlformats.org/drawingml/2006/chart" r:id="R52afaeba3c9d47dc"/>
           </a:graphicData>
         </a:graphic>
       </p:graphicFrame>
@@ -14632,7 +14632,7 @@
           <p:cNvPr id="4" name="">
             <a:extLst xmlns:a="http://schemas.openxmlformats.org/drawingml/2006/main">
               <a:ext uri="{FF2B5EF4-FFF2-40B4-BE49-F238E27FC236}">
-                <a16:creationId xmlns:a16="http://schemas.microsoft.com/office/drawing/2014/main" id="{531F77C9-2990-44E7-B0A0-FB55B57F0F20}"/>
+                <a16:creationId xmlns:a16="http://schemas.microsoft.com/office/drawing/2014/main" id="{466CF727-CB6B-4623-B84A-A32C319B703B}"/>
               </a:ext>
             </a:extLst>
           </p:cNvPr>
@@ -14700,7 +14700,7 @@
           <p:cNvPr id="5" name="">
             <a:extLst xmlns:a="http://schemas.openxmlformats.org/drawingml/2006/main">
               <a:ext uri="{FF2B5EF4-FFF2-40B4-BE49-F238E27FC236}">
-                <a16:creationId xmlns:a16="http://schemas.microsoft.com/office/drawing/2014/main" id="{3176B0FF-7F3A-4D3C-9FDF-193F763D7731}"/>
+                <a16:creationId xmlns:a16="http://schemas.microsoft.com/office/drawing/2014/main" id="{D8F30F44-A6C2-4E30-AD66-400FCF9508AC}"/>
               </a:ext>
             </a:extLst>
           </p:cNvPr>
@@ -14791,7 +14791,7 @@
           <p:cNvPr id="6" name="">
             <a:extLst xmlns:a="http://schemas.openxmlformats.org/drawingml/2006/main">
               <a:ext uri="{FF2B5EF4-FFF2-40B4-BE49-F238E27FC236}">
-                <a16:creationId xmlns:a16="http://schemas.microsoft.com/office/drawing/2014/main" id="{F2B35200-BB55-4A6B-90E5-967D26EBD5BF}"/>
+                <a16:creationId xmlns:a16="http://schemas.microsoft.com/office/drawing/2014/main" id="{2DB66B94-A50A-430B-ADA8-7E9D90AEC3D6}"/>
               </a:ext>
             </a:extLst>
           </p:cNvPr>
@@ -14859,7 +14859,7 @@
           <p:cNvPr id="7" name="">
             <a:extLst xmlns:a="http://schemas.openxmlformats.org/drawingml/2006/main">
               <a:ext uri="{FF2B5EF4-FFF2-40B4-BE49-F238E27FC236}">
-                <a16:creationId xmlns:a16="http://schemas.microsoft.com/office/drawing/2014/main" id="{FAD82AB0-62C3-48C2-9A44-5FA7C81F41A9}"/>
+                <a16:creationId xmlns:a16="http://schemas.microsoft.com/office/drawing/2014/main" id="{56F9ED1B-88C9-46DB-B953-F0A99AD5C828}"/>
               </a:ext>
             </a:extLst>
           </p:cNvPr>
@@ -14948,7 +14948,7 @@
     </p:spTree>
     <p:extLst>
       <p:ext uri="{BB962C8B-B14F-4D97-AF65-F5344CB8AC3E}">
-        <p14:creationId xmlns:p14="http://schemas.microsoft.com/office/powerpoint/2010/main" val="33430366"/>
+        <p14:creationId xmlns:p14="http://schemas.microsoft.com/office/powerpoint/2010/main" val="1613156839"/>
       </p:ext>
     </p:extLst>
   </p:cSld>
@@ -14979,7 +14979,7 @@
           <p:cNvPr id="9" name="">
             <a:extLst xmlns:a="http://schemas.openxmlformats.org/drawingml/2006/main">
               <a:ext uri="{FF2B5EF4-FFF2-40B4-BE49-F238E27FC236}">
-                <a16:creationId xmlns:a16="http://schemas.microsoft.com/office/drawing/2014/main" id="{BFC42BD4-5079-4E07-9A51-DA8D0F47E85B}"/>
+                <a16:creationId xmlns:a16="http://schemas.microsoft.com/office/drawing/2014/main" id="{C5C22C2F-62EB-4E36-831E-5FE8940CF3EB}"/>
               </a:ext>
             </a:extLst>
           </p:cNvPr>
@@ -15047,7 +15047,7 @@
           <p:cNvPr id="2" name="">
             <a:extLst xmlns:a="http://schemas.openxmlformats.org/drawingml/2006/main">
               <a:ext uri="{FF2B5EF4-FFF2-40B4-BE49-F238E27FC236}">
-                <a16:creationId xmlns:a16="http://schemas.microsoft.com/office/drawing/2014/main" id="{7D01D178-F7EF-47D4-BF39-42923F639740}"/>
+                <a16:creationId xmlns:a16="http://schemas.microsoft.com/office/drawing/2014/main" id="{8FC0E3B8-1400-4B5D-BB44-94E455EBACDB}"/>
               </a:ext>
             </a:extLst>
           </p:cNvPr>
@@ -15115,7 +15115,7 @@
           <p:cNvPr id="3" name="">
             <a:extLst xmlns:a="http://schemas.openxmlformats.org/drawingml/2006/main">
               <a:ext uri="{FF2B5EF4-FFF2-40B4-BE49-F238E27FC236}">
-                <a16:creationId xmlns:a16="http://schemas.microsoft.com/office/drawing/2014/main" id="{201767B4-1411-410C-99D9-32DFC6A2D48C}"/>
+                <a16:creationId xmlns:a16="http://schemas.microsoft.com/office/drawing/2014/main" id="{214D0428-4A1E-44DF-8D95-E87B9A42CEA4}"/>
               </a:ext>
             </a:extLst>
           </p:cNvPr>
@@ -15183,7 +15183,7 @@
           <p:cNvPr id="4" name="">
             <a:extLst xmlns:a="http://schemas.openxmlformats.org/drawingml/2006/main">
               <a:ext uri="{FF2B5EF4-FFF2-40B4-BE49-F238E27FC236}">
-                <a16:creationId xmlns:a16="http://schemas.microsoft.com/office/drawing/2014/main" id="{9BCEB8A9-DA19-4662-A25E-B7868ED75517}"/>
+                <a16:creationId xmlns:a16="http://schemas.microsoft.com/office/drawing/2014/main" id="{4A427DB6-6209-4492-8ACA-6E73F6A3854A}"/>
               </a:ext>
             </a:extLst>
           </p:cNvPr>
@@ -15251,7 +15251,7 @@
           <p:cNvPr id="5" name="">
             <a:extLst xmlns:a="http://schemas.openxmlformats.org/drawingml/2006/main">
               <a:ext uri="{FF2B5EF4-FFF2-40B4-BE49-F238E27FC236}">
-                <a16:creationId xmlns:a16="http://schemas.microsoft.com/office/drawing/2014/main" id="{8F134C50-64CD-417A-97A4-D6DF1167DC2D}"/>
+                <a16:creationId xmlns:a16="http://schemas.microsoft.com/office/drawing/2014/main" id="{F2B124BA-ABF3-4E99-9522-89072F47740A}"/>
               </a:ext>
             </a:extLst>
           </p:cNvPr>
@@ -15319,7 +15319,7 @@
           <p:cNvPr id="6" name="">
             <a:extLst xmlns:a="http://schemas.openxmlformats.org/drawingml/2006/main">
               <a:ext uri="{FF2B5EF4-FFF2-40B4-BE49-F238E27FC236}">
-                <a16:creationId xmlns:a16="http://schemas.microsoft.com/office/drawing/2014/main" id="{EFA549AB-CD15-49EE-AA48-4FFD492E285E}"/>
+                <a16:creationId xmlns:a16="http://schemas.microsoft.com/office/drawing/2014/main" id="{9DE71C4F-0AC6-41F9-92FA-CB1A32B20F3E}"/>
               </a:ext>
             </a:extLst>
           </p:cNvPr>
@@ -15387,7 +15387,7 @@
           <p:cNvPr id="7" name="">
             <a:extLst xmlns:a="http://schemas.openxmlformats.org/drawingml/2006/main">
               <a:ext uri="{FF2B5EF4-FFF2-40B4-BE49-F238E27FC236}">
-                <a16:creationId xmlns:a16="http://schemas.microsoft.com/office/drawing/2014/main" id="{25FA3919-AF35-4E4A-97BD-39A7633E0983}"/>
+                <a16:creationId xmlns:a16="http://schemas.microsoft.com/office/drawing/2014/main" id="{C4B5D33F-68E5-42CD-AAB7-ED32DE55302D}"/>
               </a:ext>
             </a:extLst>
           </p:cNvPr>
@@ -15638,7 +15638,7 @@
           <p:cNvPr id="8" name="">
             <a:extLst xmlns:a="http://schemas.openxmlformats.org/drawingml/2006/main">
               <a:ext uri="{FF2B5EF4-FFF2-40B4-BE49-F238E27FC236}">
-                <a16:creationId xmlns:a16="http://schemas.microsoft.com/office/drawing/2014/main" id="{223A260A-9BC4-45A0-94DD-38ABCAF7DD9F}"/>
+                <a16:creationId xmlns:a16="http://schemas.microsoft.com/office/drawing/2014/main" id="{7E9EA771-D264-418E-90AC-6EE95E7B9B0E}"/>
               </a:ext>
             </a:extLst>
           </p:cNvPr>
@@ -15727,7 +15727,7 @@
     </p:spTree>
     <p:extLst>
       <p:ext uri="{BB962C8B-B14F-4D97-AF65-F5344CB8AC3E}">
-        <p14:creationId xmlns:p14="http://schemas.microsoft.com/office/powerpoint/2010/main" val="592634975"/>
+        <p14:creationId xmlns:p14="http://schemas.microsoft.com/office/powerpoint/2010/main" val="1288813762"/>
       </p:ext>
     </p:extLst>
   </p:cSld>
@@ -15758,7 +15758,7 @@
           <p:cNvPr id="8" name="">
             <a:extLst xmlns:a="http://schemas.openxmlformats.org/drawingml/2006/main">
               <a:ext uri="{FF2B5EF4-FFF2-40B4-BE49-F238E27FC236}">
-                <a16:creationId xmlns:a16="http://schemas.microsoft.com/office/drawing/2014/main" id="{A7FF853B-6DC1-484C-8EE6-E285A4F7FD11}"/>
+                <a16:creationId xmlns:a16="http://schemas.microsoft.com/office/drawing/2014/main" id="{287483B9-1074-4750-BBAF-19E8868401D1}"/>
               </a:ext>
             </a:extLst>
           </p:cNvPr>
@@ -15826,7 +15826,7 @@
           <p:cNvPr id="2" name="">
             <a:extLst xmlns:a="http://schemas.openxmlformats.org/drawingml/2006/main">
               <a:ext uri="{FF2B5EF4-FFF2-40B4-BE49-F238E27FC236}">
-                <a16:creationId xmlns:a16="http://schemas.microsoft.com/office/drawing/2014/main" id="{DF313199-34B5-4781-93C8-5FD4FD43B74E}"/>
+                <a16:creationId xmlns:a16="http://schemas.microsoft.com/office/drawing/2014/main" id="{24BBB2DE-4D9C-47EA-809E-D5BF2006DAAD}"/>
               </a:ext>
             </a:extLst>
           </p:cNvPr>
@@ -15894,7 +15894,7 @@
           <p:cNvPr id="3" name="">
             <a:extLst xmlns:a="http://schemas.openxmlformats.org/drawingml/2006/main">
               <a:ext uri="{FF2B5EF4-FFF2-40B4-BE49-F238E27FC236}">
-                <a16:creationId xmlns:a16="http://schemas.microsoft.com/office/drawing/2014/main" id="{F358BFF7-F1A6-4ED9-86F0-7D06E860F89D}"/>
+                <a16:creationId xmlns:a16="http://schemas.microsoft.com/office/drawing/2014/main" id="{0F70EA17-B784-432B-849C-9ABA08CF80D4}"/>
               </a:ext>
             </a:extLst>
           </p:cNvPr>
@@ -15962,7 +15962,7 @@
           <p:cNvPr id="4" name="">
             <a:extLst xmlns:a="http://schemas.openxmlformats.org/drawingml/2006/main">
               <a:ext uri="{FF2B5EF4-FFF2-40B4-BE49-F238E27FC236}">
-                <a16:creationId xmlns:a16="http://schemas.microsoft.com/office/drawing/2014/main" id="{71906A73-21A9-4700-8314-0FC449A39E8F}"/>
+                <a16:creationId xmlns:a16="http://schemas.microsoft.com/office/drawing/2014/main" id="{C075158D-1C13-435B-84B4-5D998F82BFA8}"/>
               </a:ext>
             </a:extLst>
           </p:cNvPr>
@@ -16030,7 +16030,7 @@
           <p:cNvPr id="5" name="Chart">
             <a:extLst xmlns:a="http://schemas.openxmlformats.org/drawingml/2006/main">
               <a:ext uri="{FF2B5EF4-FFF2-40B4-BE49-F238E27FC236}">
-                <a16:creationId xmlns:a16="http://schemas.microsoft.com/office/drawing/2014/main" id="{0F2CA848-8D55-4099-92B1-4055CC7A7289}"/>
+                <a16:creationId xmlns:a16="http://schemas.microsoft.com/office/drawing/2014/main" id="{98489F92-5D83-40CB-95FB-42CF8888F810}"/>
               </a:ext>
             </a:extLst>
           </p:cNvPr>
@@ -16043,7 +16043,7 @@
         </p:xfrm>
         <a:graphic xmlns:a="http://schemas.openxmlformats.org/drawingml/2006/main">
           <a:graphicData uri="http://schemas.openxmlformats.org/drawingml/2006/chart">
-            <c:chart xmlns:r="http://schemas.openxmlformats.org/officeDocument/2006/relationships" xmlns:c="http://schemas.openxmlformats.org/drawingml/2006/chart" r:id="R06f95844ec5a4a75"/>
+            <c:chart xmlns:r="http://schemas.openxmlformats.org/officeDocument/2006/relationships" xmlns:c="http://schemas.openxmlformats.org/drawingml/2006/chart" r:id="R6b7974326c1644e6"/>
           </a:graphicData>
         </a:graphic>
       </p:graphicFrame>
@@ -16052,7 +16052,7 @@
           <p:cNvPr id="6" name="Chart">
             <a:extLst xmlns:a="http://schemas.openxmlformats.org/drawingml/2006/main">
               <a:ext uri="{FF2B5EF4-FFF2-40B4-BE49-F238E27FC236}">
-                <a16:creationId xmlns:a16="http://schemas.microsoft.com/office/drawing/2014/main" id="{A9214989-6012-482D-9F19-B2B9273CC17D}"/>
+                <a16:creationId xmlns:a16="http://schemas.microsoft.com/office/drawing/2014/main" id="{DC53281E-109F-456A-82B8-90E69E245C40}"/>
               </a:ext>
             </a:extLst>
           </p:cNvPr>
@@ -16065,7 +16065,7 @@
         </p:xfrm>
         <a:graphic xmlns:a="http://schemas.openxmlformats.org/drawingml/2006/main">
           <a:graphicData uri="http://schemas.openxmlformats.org/drawingml/2006/chart">
-            <c:chart xmlns:r="http://schemas.openxmlformats.org/officeDocument/2006/relationships" xmlns:c="http://schemas.openxmlformats.org/drawingml/2006/chart" r:id="R78d1fa5d108141e8"/>
+            <c:chart xmlns:r="http://schemas.openxmlformats.org/officeDocument/2006/relationships" xmlns:c="http://schemas.openxmlformats.org/drawingml/2006/chart" r:id="R93e3acdb629d4ad9"/>
           </a:graphicData>
         </a:graphic>
       </p:graphicFrame>
@@ -16074,7 +16074,7 @@
           <p:cNvPr id="7" name="">
             <a:extLst xmlns:a="http://schemas.openxmlformats.org/drawingml/2006/main">
               <a:ext uri="{FF2B5EF4-FFF2-40B4-BE49-F238E27FC236}">
-                <a16:creationId xmlns:a16="http://schemas.microsoft.com/office/drawing/2014/main" id="{0B238250-DCE6-4963-AAEF-867D70616D9A}"/>
+                <a16:creationId xmlns:a16="http://schemas.microsoft.com/office/drawing/2014/main" id="{653ABDBF-4A27-47B3-B02F-B1AE204D31E1}"/>
               </a:ext>
             </a:extLst>
           </p:cNvPr>
@@ -16132,7 +16132,7 @@
                 <a:ea typeface="Calibri"/>
                 <a:cs typeface="Calibri"/>
               </a:rPr>
-              <a:t>Bootstrap 95% AP interval: 0.683â€“0.820, conditional on the fixed model and test split.</a:t>
+              <a:t>Bootstrap 95% AP interval: 0.683–0.820, conditional on the fixed model and test split.</a:t>
             </a:r>
           </a:p>
         </p:txBody>
@@ -16140,7 +16140,7 @@
     </p:spTree>
     <p:extLst>
       <p:ext uri="{BB962C8B-B14F-4D97-AF65-F5344CB8AC3E}">
-        <p14:creationId xmlns:p14="http://schemas.microsoft.com/office/powerpoint/2010/main" val="1944914593"/>
+        <p14:creationId xmlns:p14="http://schemas.microsoft.com/office/powerpoint/2010/main" val="1726079891"/>
       </p:ext>
     </p:extLst>
   </p:cSld>

</xml_diff>